<commit_message>
Remplace les prompts vidéo de l'annexe par les quatre plans les plus sûrs
L'annexe du deck reprend désormais les plans 01 ouverture, 02 façade,
06 révélation et 11 insertion urbaine, sur quatre colonnes. Chaque prompt
porte le terme de mouvement en anglais, que le modèle interprète mieux
que sa traduction.

Ajoute la grammaire vidéo complète en annexe HTML : douze fiches de plan
avec découpage technique, vocabulaire de plateau et pièges par plan.

Co-Authored-By: Claude Opus 5 <noreply@anthropic.com>
Claude-Session: https://claude.ai/code/session_01WhV3N8MPsWKFQFiEbmGu2X
</commit_message>
<xml_diff>
--- a/formation-ia-architectes/formation-ia-architectes.pptx
+++ b/formation-ia-architectes/formation-ia-architectes.pptx
@@ -1711,7 +1711,8 @@
             <a:r>
               <a:rPr lang="en-US" dirty="0"/>
               <a:t>4 minutes. Idéalement, avoir un exemple généré de chacun des quatre mouvements. Si vous n'en avez que deux, prenez le travelling avant et le survol.
-Utiliser leur vocabulaire de cinéma, pas les termes anglais des interfaces — ils comprennent mieux et retiennent mieux.</a:t>
+Utiliser leur vocabulaire de cinéma pour expliquer, mais écrire le terme de mouvement en anglais dans le prompt : le modèle a été entraîné sur dolly in, tracking shot, tilt up, orbit.
+Les douze plans complets, avec leur découpage technique et ce qui les casse, sont dans la Grammaire vidéo Seedance remise avec le support. Quatre d'entre eux sont repris en annexe du deck.</a:t>
             </a:r>
             <a:endParaRPr lang="en-US" dirty="0"/>
           </a:p>
@@ -2702,9 +2703,10 @@
             <a:r>
               <a:rPr lang="en-US" dirty="0"/>
               <a:t>Annexe à envoyer en PDF après la session, et à copier dans leur fichier de prompts pendant la session.
-Les trois prompts vidéo respectent la règle d'or : caméra et sujet dans des phrases séparées. Leur faire remarquer la longueur — entre 50 et 70 mots, la zone où le modèle est le plus fiable.
-Le prompt « esquisse vers maquette blanche » est celui qui surprend le plus favorablement les architectes : il correspond à un geste qu'ils connaissent déjà et qu'ils font à la main.
-Le survol précise « aucun personnage en mouvement » : c'est le garde-fou contre le piège du staffage animé.</a:t>
+Les quatre prompts vidéo sont volontairement les plus sûrs : travelling avant, travelling latéral, révélation, accompagnement steadicam. Ce sont ceux qui passent en atelier sans mauvaise surprise.
+Les crochets sont volontaires : ce sont les emplacements qu'ils remplissent avec leur propre vocabulaire. Un prompt entièrement pré-écrit ne s'approprie pas.
+Remarquer avec eux que le terme de mouvement est en anglais et le reste en français : le modèle a été entraîné sur le vocabulaire de plateau anglophone, dolly in et tracking shot portent mieux que leurs traductions.
+Le prompt esquisse vers maquette blanche est celui qui surprend le plus favorablement les architectes : il correspond à un geste qu'ils font déjà à la main.</a:t>
             </a:r>
             <a:endParaRPr lang="en-US" dirty="0"/>
           </a:p>
@@ -31008,11 +31010,11 @@
         <p:spPr>
           <a:xfrm>
             <a:off x="566928" y="1389888"/>
-            <a:ext cx="3533546" cy="1956816"/>
+            <a:ext cx="3533546" cy="1901952"/>
           </a:xfrm>
           <a:prstGeom prst="roundRect">
             <a:avLst>
-              <a:gd name="adj" fmla="val 3738"/>
+              <a:gd name="adj" fmla="val 3846"/>
             </a:avLst>
           </a:prstGeom>
           <a:solidFill>
@@ -31069,7 +31071,7 @@
         <p:spPr>
           <a:xfrm>
             <a:off x="749808" y="1773936"/>
-            <a:ext cx="3167786" cy="1426464"/>
+            <a:ext cx="3167786" cy="1371600"/>
           </a:xfrm>
           <a:prstGeom prst="rect">
             <a:avLst/>
@@ -31260,11 +31262,11 @@
         <p:spPr>
           <a:xfrm>
             <a:off x="4329074" y="1389888"/>
-            <a:ext cx="3533546" cy="1956816"/>
+            <a:ext cx="3533546" cy="1901952"/>
           </a:xfrm>
           <a:prstGeom prst="roundRect">
             <a:avLst>
-              <a:gd name="adj" fmla="val 3738"/>
+              <a:gd name="adj" fmla="val 3846"/>
             </a:avLst>
           </a:prstGeom>
           <a:solidFill>
@@ -31321,7 +31323,7 @@
         <p:spPr>
           <a:xfrm>
             <a:off x="4511954" y="1773936"/>
-            <a:ext cx="3167786" cy="1426464"/>
+            <a:ext cx="3167786" cy="1371600"/>
           </a:xfrm>
           <a:prstGeom prst="rect">
             <a:avLst/>
@@ -31512,11 +31514,11 @@
         <p:spPr>
           <a:xfrm>
             <a:off x="8091221" y="1389888"/>
-            <a:ext cx="3533546" cy="1956816"/>
+            <a:ext cx="3533546" cy="1901952"/>
           </a:xfrm>
           <a:prstGeom prst="roundRect">
             <a:avLst>
-              <a:gd name="adj" fmla="val 3738"/>
+              <a:gd name="adj" fmla="val 3846"/>
             </a:avLst>
           </a:prstGeom>
           <a:solidFill>
@@ -31573,7 +31575,7 @@
         <p:spPr>
           <a:xfrm>
             <a:off x="8274101" y="1773936"/>
-            <a:ext cx="3167786" cy="1426464"/>
+            <a:ext cx="3167786" cy="1371600"/>
           </a:xfrm>
           <a:prstGeom prst="rect">
             <a:avLst/>
@@ -31772,12 +31774,12 @@
         </p:nvSpPr>
         <p:spPr>
           <a:xfrm>
-            <a:off x="566928" y="3547872"/>
-            <a:ext cx="3533546" cy="1956816"/>
+            <a:off x="566928" y="3419856"/>
+            <a:ext cx="2593010" cy="2084832"/>
           </a:xfrm>
           <a:prstGeom prst="roundRect">
             <a:avLst>
-              <a:gd name="adj" fmla="val 3738"/>
+              <a:gd name="adj" fmla="val 3509"/>
             </a:avLst>
           </a:prstGeom>
           <a:solidFill>
@@ -31794,8 +31796,8 @@
         </p:nvSpPr>
         <p:spPr>
           <a:xfrm>
-            <a:off x="749808" y="3675888"/>
-            <a:ext cx="3167786" cy="219456"/>
+            <a:off x="749808" y="3547872"/>
+            <a:ext cx="2227250" cy="219456"/>
           </a:xfrm>
           <a:prstGeom prst="rect">
             <a:avLst/>
@@ -31819,7 +31821,7 @@
                 <a:ea typeface="Calibri" pitchFamily="34" charset="-122"/>
                 <a:cs typeface="Calibri" pitchFamily="34" charset="-120"/>
               </a:rPr>
-              <a:t>VIDÉO · TRAVELLING AVANT</a:t>
+              <a:t>PLAN 01 · OUVERTURE</a:t>
             </a:r>
             <a:endParaRPr lang="en-US" sz="900" dirty="0"/>
           </a:p>
@@ -31833,8 +31835,8 @@
         </p:nvSpPr>
         <p:spPr>
           <a:xfrm>
-            <a:off x="749808" y="3931920"/>
-            <a:ext cx="3167786" cy="1426464"/>
+            <a:off x="749808" y="3803904"/>
+            <a:ext cx="2227250" cy="1554480"/>
           </a:xfrm>
           <a:prstGeom prst="rect">
             <a:avLst/>
@@ -31853,7 +31855,7 @@
               <a:buNone/>
             </a:pPr>
             <a:r>
-              <a:rPr lang="en-US" sz="900" dirty="0">
+              <a:rPr lang="en-US" sz="800" dirty="0">
                 <a:solidFill>
                   <a:srgbClr val="DFE5E8"/>
                 </a:solidFill>
@@ -31861,9 +31863,9 @@
                 <a:ea typeface="Consolas" pitchFamily="34" charset="-122"/>
                 <a:cs typeface="Consolas" pitchFamily="34" charset="-120"/>
               </a:rPr>
-              <a:t>Photographie d'architecture d'une</a:t>
-            </a:r>
-            <a:endParaRPr lang="en-US" sz="900" dirty="0"/>
+              <a:t>Photographie d'architecture d'un</a:t>
+            </a:r>
+            <a:endParaRPr lang="en-US" sz="800" dirty="0"/>
           </a:p>
           <a:p>
             <a:pPr indent="0" marL="0">
@@ -31873,7 +31875,7 @@
               <a:buNone/>
             </a:pPr>
             <a:r>
-              <a:rPr lang="en-US" sz="900" dirty="0">
+              <a:rPr lang="en-US" sz="800" dirty="0">
                 <a:solidFill>
                   <a:srgbClr val="DFE5E8"/>
                 </a:solidFill>
@@ -31881,9 +31883,9 @@
                 <a:ea typeface="Consolas" pitchFamily="34" charset="-122"/>
                 <a:cs typeface="Consolas" pitchFamily="34" charset="-120"/>
               </a:rPr>
-              <a:t>[typologie] en [matériau], en fin</a:t>
-            </a:r>
-            <a:endParaRPr lang="en-US" sz="900" dirty="0"/>
+              <a:t>[typologie] en [matériau], fin</a:t>
+            </a:r>
+            <a:endParaRPr lang="en-US" sz="800" dirty="0"/>
           </a:p>
           <a:p>
             <a:pPr indent="0" marL="0">
@@ -31893,7 +31895,7 @@
               <a:buNone/>
             </a:pPr>
             <a:r>
-              <a:rPr lang="en-US" sz="900" dirty="0">
+              <a:rPr lang="en-US" sz="800" dirty="0">
                 <a:solidFill>
                   <a:srgbClr val="DFE5E8"/>
                 </a:solidFill>
@@ -31901,9 +31903,9 @@
                 <a:ea typeface="Consolas" pitchFamily="34" charset="-122"/>
                 <a:cs typeface="Consolas" pitchFamily="34" charset="-120"/>
               </a:rPr>
-              <a:t>d'après-midi.</a:t>
-            </a:r>
-            <a:endParaRPr lang="en-US" sz="900" dirty="0"/>
+              <a:t>d'après-midi, ombres longues.</a:t>
+            </a:r>
+            <a:endParaRPr lang="en-US" sz="800" dirty="0"/>
           </a:p>
           <a:p>
             <a:pPr indent="0" marL="0">
@@ -31912,7 +31914,7 @@
               </a:lnSpc>
               <a:buNone/>
             </a:pPr>
-            <a:endParaRPr lang="en-US" sz="900" dirty="0"/>
+            <a:endParaRPr lang="en-US" sz="800" dirty="0"/>
           </a:p>
           <a:p>
             <a:pPr indent="0" marL="0">
@@ -31922,7 +31924,7 @@
               <a:buNone/>
             </a:pPr>
             <a:r>
-              <a:rPr lang="en-US" sz="900" dirty="0">
+              <a:rPr lang="en-US" sz="800" dirty="0">
                 <a:solidFill>
                   <a:srgbClr val="DFE5E8"/>
                 </a:solidFill>
@@ -31930,9 +31932,9 @@
                 <a:ea typeface="Consolas" pitchFamily="34" charset="-122"/>
                 <a:cs typeface="Consolas" pitchFamily="34" charset="-120"/>
               </a:rPr>
-              <a:t>La caméra avance lentement et</a:t>
-            </a:r>
-            <a:endParaRPr lang="en-US" sz="900" dirty="0"/>
+              <a:t>Caméra : slow dolly in. Elle avance</a:t>
+            </a:r>
+            <a:endParaRPr lang="en-US" sz="800" dirty="0"/>
           </a:p>
           <a:p>
             <a:pPr indent="0" marL="0">
@@ -31942,7 +31944,7 @@
               <a:buNone/>
             </a:pPr>
             <a:r>
-              <a:rPr lang="en-US" sz="900" dirty="0">
+              <a:rPr lang="en-US" sz="800" dirty="0">
                 <a:solidFill>
                   <a:srgbClr val="DFE5E8"/>
                 </a:solidFill>
@@ -31950,9 +31952,9 @@
                 <a:ea typeface="Consolas" pitchFamily="34" charset="-122"/>
                 <a:cs typeface="Consolas" pitchFamily="34" charset="-120"/>
               </a:rPr>
-              <a:t>régulièrement vers l'entrée, hauteur</a:t>
-            </a:r>
-            <a:endParaRPr lang="en-US" sz="900" dirty="0"/>
+              <a:t>lentement vers l'entrée, hauteur</a:t>
+            </a:r>
+            <a:endParaRPr lang="en-US" sz="800" dirty="0"/>
           </a:p>
           <a:p>
             <a:pPr indent="0" marL="0">
@@ -31962,7 +31964,7 @@
               <a:buNone/>
             </a:pPr>
             <a:r>
-              <a:rPr lang="en-US" sz="900" dirty="0">
+              <a:rPr lang="en-US" sz="800" dirty="0">
                 <a:solidFill>
                   <a:srgbClr val="DFE5E8"/>
                 </a:solidFill>
@@ -31972,7 +31974,7 @@
               </a:rPr>
               <a:t>constante, sans à-coups.</a:t>
             </a:r>
-            <a:endParaRPr lang="en-US" sz="900" dirty="0"/>
+            <a:endParaRPr lang="en-US" sz="800" dirty="0"/>
           </a:p>
           <a:p>
             <a:pPr indent="0" marL="0">
@@ -31981,7 +31983,7 @@
               </a:lnSpc>
               <a:buNone/>
             </a:pPr>
-            <a:endParaRPr lang="en-US" sz="900" dirty="0"/>
+            <a:endParaRPr lang="en-US" sz="800" dirty="0"/>
           </a:p>
           <a:p>
             <a:pPr indent="0" marL="0">
@@ -31991,7 +31993,7 @@
               <a:buNone/>
             </a:pPr>
             <a:r>
-              <a:rPr lang="en-US" sz="900" dirty="0">
+              <a:rPr lang="en-US" sz="800" dirty="0">
                 <a:solidFill>
                   <a:srgbClr val="DFE5E8"/>
                 </a:solidFill>
@@ -31999,9 +32001,9 @@
                 <a:ea typeface="Consolas" pitchFamily="34" charset="-122"/>
                 <a:cs typeface="Consolas" pitchFamily="34" charset="-120"/>
               </a:rPr>
-              <a:t>Le feuillage bouge légèrement au vent.</a:t>
-            </a:r>
-            <a:endParaRPr lang="en-US" sz="900" dirty="0"/>
+              <a:t>Le feuillage bouge légèrement.</a:t>
+            </a:r>
+            <a:endParaRPr lang="en-US" sz="800" dirty="0"/>
           </a:p>
           <a:p>
             <a:pPr indent="0" marL="0">
@@ -32010,7 +32012,7 @@
               </a:lnSpc>
               <a:buNone/>
             </a:pPr>
-            <a:endParaRPr lang="en-US" sz="900" dirty="0"/>
+            <a:endParaRPr lang="en-US" sz="800" dirty="0"/>
           </a:p>
           <a:p>
             <a:pPr indent="0" marL="0">
@@ -32020,7 +32022,7 @@
               <a:buNone/>
             </a:pPr>
             <a:r>
-              <a:rPr lang="en-US" sz="900" dirty="0">
+              <a:rPr lang="en-US" sz="800" dirty="0">
                 <a:solidFill>
                   <a:srgbClr val="DFE5E8"/>
                 </a:solidFill>
@@ -32028,9 +32030,9 @@
                 <a:ea typeface="Consolas" pitchFamily="34" charset="-122"/>
                 <a:cs typeface="Consolas" pitchFamily="34" charset="-120"/>
               </a:rPr>
-              <a:t>Aucun son. Un plan, six secondes.</a:t>
-            </a:r>
-            <a:endParaRPr lang="en-US" sz="900" dirty="0"/>
+              <a:t>Un plan, six secondes. Aucun son.</a:t>
+            </a:r>
+            <a:endParaRPr lang="en-US" sz="800" dirty="0"/>
           </a:p>
         </p:txBody>
       </p:sp>
@@ -32042,12 +32044,12 @@
         </p:nvSpPr>
         <p:spPr>
           <a:xfrm>
-            <a:off x="4329074" y="3547872"/>
-            <a:ext cx="3533546" cy="1956816"/>
+            <a:off x="3388538" y="3419856"/>
+            <a:ext cx="2593010" cy="2084832"/>
           </a:xfrm>
           <a:prstGeom prst="roundRect">
             <a:avLst>
-              <a:gd name="adj" fmla="val 3738"/>
+              <a:gd name="adj" fmla="val 3509"/>
             </a:avLst>
           </a:prstGeom>
           <a:solidFill>
@@ -32064,8 +32066,8 @@
         </p:nvSpPr>
         <p:spPr>
           <a:xfrm>
-            <a:off x="4511954" y="3675888"/>
-            <a:ext cx="3167786" cy="219456"/>
+            <a:off x="3571418" y="3547872"/>
+            <a:ext cx="2227250" cy="219456"/>
           </a:xfrm>
           <a:prstGeom prst="rect">
             <a:avLst/>
@@ -32089,7 +32091,7 @@
                 <a:ea typeface="Calibri" pitchFamily="34" charset="-122"/>
                 <a:cs typeface="Calibri" pitchFamily="34" charset="-120"/>
               </a:rPr>
-              <a:t>VIDÉO · PANORAMIQUE DE FAÇADE</a:t>
+              <a:t>PLAN 02 · FAÇADE</a:t>
             </a:r>
             <a:endParaRPr lang="en-US" sz="900" dirty="0"/>
           </a:p>
@@ -32103,8 +32105,8 @@
         </p:nvSpPr>
         <p:spPr>
           <a:xfrm>
-            <a:off x="4511954" y="3931920"/>
-            <a:ext cx="3167786" cy="1426464"/>
+            <a:off x="3571418" y="3803904"/>
+            <a:ext cx="2227250" cy="1554480"/>
           </a:xfrm>
           <a:prstGeom prst="rect">
             <a:avLst/>
@@ -32123,7 +32125,7 @@
               <a:buNone/>
             </a:pPr>
             <a:r>
-              <a:rPr lang="en-US" sz="900" dirty="0">
+              <a:rPr lang="en-US" sz="800" dirty="0">
                 <a:solidFill>
                   <a:srgbClr val="DFE5E8"/>
                 </a:solidFill>
@@ -32133,7 +32135,7 @@
               </a:rPr>
               <a:t>Façade sud d'un [typologie] en</a:t>
             </a:r>
-            <a:endParaRPr lang="en-US" sz="900" dirty="0"/>
+            <a:endParaRPr lang="en-US" sz="800" dirty="0"/>
           </a:p>
           <a:p>
             <a:pPr indent="0" marL="0">
@@ -32143,7 +32145,7 @@
               <a:buNone/>
             </a:pPr>
             <a:r>
-              <a:rPr lang="en-US" sz="900" dirty="0">
+              <a:rPr lang="en-US" sz="800" dirty="0">
                 <a:solidFill>
                   <a:srgbClr val="DFE5E8"/>
                 </a:solidFill>
@@ -32153,7 +32155,7 @@
               </a:rPr>
               <a:t>[matériau], ciel couvert uniforme.</a:t>
             </a:r>
-            <a:endParaRPr lang="en-US" sz="900" dirty="0"/>
+            <a:endParaRPr lang="en-US" sz="800" dirty="0"/>
           </a:p>
           <a:p>
             <a:pPr indent="0" marL="0">
@@ -32162,7 +32164,7 @@
               </a:lnSpc>
               <a:buNone/>
             </a:pPr>
-            <a:endParaRPr lang="en-US" sz="900" dirty="0"/>
+            <a:endParaRPr lang="en-US" sz="800" dirty="0"/>
           </a:p>
           <a:p>
             <a:pPr indent="0" marL="0">
@@ -32172,7 +32174,7 @@
               <a:buNone/>
             </a:pPr>
             <a:r>
-              <a:rPr lang="en-US" sz="900" dirty="0">
+              <a:rPr lang="en-US" sz="800" dirty="0">
                 <a:solidFill>
                   <a:srgbClr val="DFE5E8"/>
                 </a:solidFill>
@@ -32180,9 +32182,9 @@
                 <a:ea typeface="Consolas" pitchFamily="34" charset="-122"/>
                 <a:cs typeface="Consolas" pitchFamily="34" charset="-120"/>
               </a:rPr>
-              <a:t>Panoramique lent et régulier de</a:t>
-            </a:r>
-            <a:endParaRPr lang="en-US" sz="900" dirty="0"/>
+              <a:t>Caméra : slow lateral tracking</a:t>
+            </a:r>
+            <a:endParaRPr lang="en-US" sz="800" dirty="0"/>
           </a:p>
           <a:p>
             <a:pPr indent="0" marL="0">
@@ -32192,7 +32194,7 @@
               <a:buNone/>
             </a:pPr>
             <a:r>
-              <a:rPr lang="en-US" sz="900" dirty="0">
+              <a:rPr lang="en-US" sz="800" dirty="0">
                 <a:solidFill>
                   <a:srgbClr val="DFE5E8"/>
                 </a:solidFill>
@@ -32200,9 +32202,9 @@
                 <a:ea typeface="Consolas" pitchFamily="34" charset="-122"/>
                 <a:cs typeface="Consolas" pitchFamily="34" charset="-120"/>
               </a:rPr>
-              <a:t>gauche à droite, caméra fixe,</a:t>
-            </a:r>
-            <a:endParaRPr lang="en-US" sz="900" dirty="0"/>
+              <a:t>shot. Elle se déplace de gauche à</a:t>
+            </a:r>
+            <a:endParaRPr lang="en-US" sz="800" dirty="0"/>
           </a:p>
           <a:p>
             <a:pPr indent="0" marL="0">
@@ -32212,7 +32214,7 @@
               <a:buNone/>
             </a:pPr>
             <a:r>
-              <a:rPr lang="en-US" sz="900" dirty="0">
+              <a:rPr lang="en-US" sz="800" dirty="0">
                 <a:solidFill>
                   <a:srgbClr val="DFE5E8"/>
                 </a:solidFill>
@@ -32220,9 +32222,9 @@
                 <a:ea typeface="Consolas" pitchFamily="34" charset="-122"/>
                 <a:cs typeface="Consolas" pitchFamily="34" charset="-120"/>
               </a:rPr>
-              <a:t>vitesse constante.</a:t>
-            </a:r>
-            <a:endParaRPr lang="en-US" sz="900" dirty="0"/>
+              <a:t>droite parallèlement à la façade,</a:t>
+            </a:r>
+            <a:endParaRPr lang="en-US" sz="800" dirty="0"/>
           </a:p>
           <a:p>
             <a:pPr indent="0" marL="0">
@@ -32231,7 +32233,18 @@
               </a:lnSpc>
               <a:buNone/>
             </a:pPr>
-            <a:endParaRPr lang="en-US" sz="900" dirty="0"/>
+            <a:r>
+              <a:rPr lang="en-US" sz="800" dirty="0">
+                <a:solidFill>
+                  <a:srgbClr val="DFE5E8"/>
+                </a:solidFill>
+                <a:latin typeface="Consolas" pitchFamily="34" charset="0"/>
+                <a:ea typeface="Consolas" pitchFamily="34" charset="-122"/>
+                <a:cs typeface="Consolas" pitchFamily="34" charset="-120"/>
+              </a:rPr>
+              <a:t>distance constante.</a:t>
+            </a:r>
+            <a:endParaRPr lang="en-US" sz="800" dirty="0"/>
           </a:p>
           <a:p>
             <a:pPr indent="0" marL="0">
@@ -32240,8 +32253,17 @@
               </a:lnSpc>
               <a:buNone/>
             </a:pPr>
-            <a:r>
-              <a:rPr lang="en-US" sz="900" dirty="0">
+            <a:endParaRPr lang="en-US" sz="800" dirty="0"/>
+          </a:p>
+          <a:p>
+            <a:pPr indent="0" marL="0">
+              <a:lnSpc>
+                <a:spcPct val="100000"/>
+              </a:lnSpc>
+              <a:buNone/>
+            </a:pPr>
+            <a:r>
+              <a:rPr lang="en-US" sz="800" dirty="0">
                 <a:solidFill>
                   <a:srgbClr val="DFE5E8"/>
                 </a:solidFill>
@@ -32249,9 +32271,9 @@
                 <a:ea typeface="Consolas" pitchFamily="34" charset="-122"/>
                 <a:cs typeface="Consolas" pitchFamily="34" charset="-120"/>
               </a:rPr>
-              <a:t>Aucun mouvement en dehors de la</a:t>
-            </a:r>
-            <a:endParaRPr lang="en-US" sz="900" dirty="0"/>
+              <a:t>Rien ne bouge, hors la végétation.</a:t>
+            </a:r>
+            <a:endParaRPr lang="en-US" sz="800" dirty="0"/>
           </a:p>
           <a:p>
             <a:pPr indent="0" marL="0">
@@ -32260,8 +32282,17 @@
               </a:lnSpc>
               <a:buNone/>
             </a:pPr>
-            <a:r>
-              <a:rPr lang="en-US" sz="900" dirty="0">
+            <a:endParaRPr lang="en-US" sz="800" dirty="0"/>
+          </a:p>
+          <a:p>
+            <a:pPr indent="0" marL="0">
+              <a:lnSpc>
+                <a:spcPct val="100000"/>
+              </a:lnSpc>
+              <a:buNone/>
+            </a:pPr>
+            <a:r>
+              <a:rPr lang="en-US" sz="800" dirty="0">
                 <a:solidFill>
                   <a:srgbClr val="DFE5E8"/>
                 </a:solidFill>
@@ -32269,10 +32300,93 @@
                 <a:ea typeface="Consolas" pitchFamily="34" charset="-122"/>
                 <a:cs typeface="Consolas" pitchFamily="34" charset="-120"/>
               </a:rPr>
-              <a:t>végétation.</a:t>
+              <a:t>Un plan, huit secondes. Aucun son.</a:t>
+            </a:r>
+            <a:endParaRPr lang="en-US" sz="800" dirty="0"/>
+          </a:p>
+        </p:txBody>
+      </p:sp>
+      <p:sp>
+        <p:nvSpPr>
+          <p:cNvPr id="21" name="Shape 19"/>
+          <p:cNvSpPr/>
+          <p:nvPr/>
+        </p:nvSpPr>
+        <p:spPr>
+          <a:xfrm>
+            <a:off x="6210148" y="3419856"/>
+            <a:ext cx="2593010" cy="2084832"/>
+          </a:xfrm>
+          <a:prstGeom prst="roundRect">
+            <a:avLst>
+              <a:gd name="adj" fmla="val 3509"/>
+            </a:avLst>
+          </a:prstGeom>
+          <a:solidFill>
+            <a:srgbClr val="1B2126"/>
+          </a:solidFill>
+          <a:ln/>
+        </p:spPr>
+      </p:sp>
+      <p:sp>
+        <p:nvSpPr>
+          <p:cNvPr id="22" name="Text 20"/>
+          <p:cNvSpPr txBox="1"/>
+          <p:nvPr/>
+        </p:nvSpPr>
+        <p:spPr>
+          <a:xfrm>
+            <a:off x="6393028" y="3547872"/>
+            <a:ext cx="2227250" cy="219456"/>
+          </a:xfrm>
+          <a:prstGeom prst="rect">
+            <a:avLst/>
+          </a:prstGeom>
+          <a:noFill/>
+          <a:ln/>
+        </p:spPr>
+        <p:txBody>
+          <a:bodyPr wrap="square" lIns="0" tIns="0" rIns="0" bIns="0" rtlCol="0" anchor="ctr"/>
+          <a:lstStyle/>
+          <a:p>
+            <a:pPr indent="0" marL="0">
+              <a:buNone/>
+            </a:pPr>
+            <a:r>
+              <a:rPr lang="en-US" sz="900" b="1" spc="100" kern="0" dirty="0">
+                <a:solidFill>
+                  <a:srgbClr val="C0542A"/>
+                </a:solidFill>
+                <a:latin typeface="Calibri" pitchFamily="34" charset="0"/>
+                <a:ea typeface="Calibri" pitchFamily="34" charset="-122"/>
+                <a:cs typeface="Calibri" pitchFamily="34" charset="-120"/>
+              </a:rPr>
+              <a:t>PLAN 06 · RÉVÉLATION</a:t>
             </a:r>
             <a:endParaRPr lang="en-US" sz="900" dirty="0"/>
           </a:p>
+        </p:txBody>
+      </p:sp>
+      <p:sp>
+        <p:nvSpPr>
+          <p:cNvPr id="23" name="Text 21"/>
+          <p:cNvSpPr txBox="1"/>
+          <p:nvPr/>
+        </p:nvSpPr>
+        <p:spPr>
+          <a:xfrm>
+            <a:off x="6393028" y="3803904"/>
+            <a:ext cx="2227250" cy="1554480"/>
+          </a:xfrm>
+          <a:prstGeom prst="rect">
+            <a:avLst/>
+          </a:prstGeom>
+          <a:noFill/>
+          <a:ln/>
+        </p:spPr>
+        <p:txBody>
+          <a:bodyPr wrap="square" lIns="0" tIns="0" rIns="0" bIns="0" rtlCol="0" anchor="t"/>
+          <a:lstStyle/>
           <a:p>
             <a:pPr indent="0" marL="0">
               <a:lnSpc>
@@ -32280,7 +32394,18 @@
               </a:lnSpc>
               <a:buNone/>
             </a:pPr>
-            <a:endParaRPr lang="en-US" sz="900" dirty="0"/>
+            <a:r>
+              <a:rPr lang="en-US" sz="800" dirty="0">
+                <a:solidFill>
+                  <a:srgbClr val="DFE5E8"/>
+                </a:solidFill>
+                <a:latin typeface="Consolas" pitchFamily="34" charset="0"/>
+                <a:ea typeface="Consolas" pitchFamily="34" charset="-122"/>
+                <a:cs typeface="Consolas" pitchFamily="34" charset="-120"/>
+              </a:rPr>
+              <a:t>Un [typologie] partiellement</a:t>
+            </a:r>
+            <a:endParaRPr lang="en-US" sz="800" dirty="0"/>
           </a:p>
           <a:p>
             <a:pPr indent="0" marL="0">
@@ -32290,7 +32415,7 @@
               <a:buNone/>
             </a:pPr>
             <a:r>
-              <a:rPr lang="en-US" sz="900" dirty="0">
+              <a:rPr lang="en-US" sz="800" dirty="0">
                 <a:solidFill>
                   <a:srgbClr val="DFE5E8"/>
                 </a:solidFill>
@@ -32298,26 +32423,173 @@
                 <a:ea typeface="Consolas" pitchFamily="34" charset="-122"/>
                 <a:cs typeface="Consolas" pitchFamily="34" charset="-120"/>
               </a:rPr>
-              <a:t>Aucun son. Un plan, huit secondes.</a:t>
-            </a:r>
-            <a:endParaRPr lang="en-US" sz="900" dirty="0"/>
-          </a:p>
-        </p:txBody>
-      </p:sp>
-      <p:sp>
-        <p:nvSpPr>
-          <p:cNvPr id="21" name="Shape 19"/>
+              <a:t>masqué par un premier plan de</a:t>
+            </a:r>
+            <a:endParaRPr lang="en-US" sz="800" dirty="0"/>
+          </a:p>
+          <a:p>
+            <a:pPr indent="0" marL="0">
+              <a:lnSpc>
+                <a:spcPct val="100000"/>
+              </a:lnSpc>
+              <a:buNone/>
+            </a:pPr>
+            <a:r>
+              <a:rPr lang="en-US" sz="800" dirty="0">
+                <a:solidFill>
+                  <a:srgbClr val="DFE5E8"/>
+                </a:solidFill>
+                <a:latin typeface="Consolas" pitchFamily="34" charset="0"/>
+                <a:ea typeface="Consolas" pitchFamily="34" charset="-122"/>
+                <a:cs typeface="Consolas" pitchFamily="34" charset="-120"/>
+              </a:rPr>
+              <a:t>végétation, fin d'après-midi.</a:t>
+            </a:r>
+            <a:endParaRPr lang="en-US" sz="800" dirty="0"/>
+          </a:p>
+          <a:p>
+            <a:pPr indent="0" marL="0">
+              <a:lnSpc>
+                <a:spcPct val="100000"/>
+              </a:lnSpc>
+              <a:buNone/>
+            </a:pPr>
+            <a:endParaRPr lang="en-US" sz="800" dirty="0"/>
+          </a:p>
+          <a:p>
+            <a:pPr indent="0" marL="0">
+              <a:lnSpc>
+                <a:spcPct val="100000"/>
+              </a:lnSpc>
+              <a:buNone/>
+            </a:pPr>
+            <a:r>
+              <a:rPr lang="en-US" sz="800" dirty="0">
+                <a:solidFill>
+                  <a:srgbClr val="DFE5E8"/>
+                </a:solidFill>
+                <a:latin typeface="Consolas" pitchFamily="34" charset="0"/>
+                <a:ea typeface="Consolas" pitchFamily="34" charset="-122"/>
+                <a:cs typeface="Consolas" pitchFamily="34" charset="-120"/>
+              </a:rPr>
+              <a:t>Caméra : slow reveal. Elle se</a:t>
+            </a:r>
+            <a:endParaRPr lang="en-US" sz="800" dirty="0"/>
+          </a:p>
+          <a:p>
+            <a:pPr indent="0" marL="0">
+              <a:lnSpc>
+                <a:spcPct val="100000"/>
+              </a:lnSpc>
+              <a:buNone/>
+            </a:pPr>
+            <a:r>
+              <a:rPr lang="en-US" sz="800" dirty="0">
+                <a:solidFill>
+                  <a:srgbClr val="DFE5E8"/>
+                </a:solidFill>
+                <a:latin typeface="Consolas" pitchFamily="34" charset="0"/>
+                <a:ea typeface="Consolas" pitchFamily="34" charset="-122"/>
+                <a:cs typeface="Consolas" pitchFamily="34" charset="-120"/>
+              </a:rPr>
+              <a:t>décale doucement vers la droite et</a:t>
+            </a:r>
+            <a:endParaRPr lang="en-US" sz="800" dirty="0"/>
+          </a:p>
+          <a:p>
+            <a:pPr indent="0" marL="0">
+              <a:lnSpc>
+                <a:spcPct val="100000"/>
+              </a:lnSpc>
+              <a:buNone/>
+            </a:pPr>
+            <a:r>
+              <a:rPr lang="en-US" sz="800" dirty="0">
+                <a:solidFill>
+                  <a:srgbClr val="DFE5E8"/>
+                </a:solidFill>
+                <a:latin typeface="Consolas" pitchFamily="34" charset="0"/>
+                <a:ea typeface="Consolas" pitchFamily="34" charset="-122"/>
+                <a:cs typeface="Consolas" pitchFamily="34" charset="-120"/>
+              </a:rPr>
+              <a:t>dégage le bâtiment.</a:t>
+            </a:r>
+            <a:endParaRPr lang="en-US" sz="800" dirty="0"/>
+          </a:p>
+          <a:p>
+            <a:pPr indent="0" marL="0">
+              <a:lnSpc>
+                <a:spcPct val="100000"/>
+              </a:lnSpc>
+              <a:buNone/>
+            </a:pPr>
+            <a:endParaRPr lang="en-US" sz="800" dirty="0"/>
+          </a:p>
+          <a:p>
+            <a:pPr indent="0" marL="0">
+              <a:lnSpc>
+                <a:spcPct val="100000"/>
+              </a:lnSpc>
+              <a:buNone/>
+            </a:pPr>
+            <a:r>
+              <a:rPr lang="en-US" sz="800" dirty="0">
+                <a:solidFill>
+                  <a:srgbClr val="DFE5E8"/>
+                </a:solidFill>
+                <a:latin typeface="Consolas" pitchFamily="34" charset="0"/>
+                <a:ea typeface="Consolas" pitchFamily="34" charset="-122"/>
+                <a:cs typeface="Consolas" pitchFamily="34" charset="-120"/>
+              </a:rPr>
+              <a:t>Le feuillage du premier plan bouge.</a:t>
+            </a:r>
+            <a:endParaRPr lang="en-US" sz="800" dirty="0"/>
+          </a:p>
+          <a:p>
+            <a:pPr indent="0" marL="0">
+              <a:lnSpc>
+                <a:spcPct val="100000"/>
+              </a:lnSpc>
+              <a:buNone/>
+            </a:pPr>
+            <a:endParaRPr lang="en-US" sz="800" dirty="0"/>
+          </a:p>
+          <a:p>
+            <a:pPr indent="0" marL="0">
+              <a:lnSpc>
+                <a:spcPct val="100000"/>
+              </a:lnSpc>
+              <a:buNone/>
+            </a:pPr>
+            <a:r>
+              <a:rPr lang="en-US" sz="800" dirty="0">
+                <a:solidFill>
+                  <a:srgbClr val="DFE5E8"/>
+                </a:solidFill>
+                <a:latin typeface="Consolas" pitchFamily="34" charset="0"/>
+                <a:ea typeface="Consolas" pitchFamily="34" charset="-122"/>
+                <a:cs typeface="Consolas" pitchFamily="34" charset="-120"/>
+              </a:rPr>
+              <a:t>Un plan, six secondes. Vent léger.</a:t>
+            </a:r>
+            <a:endParaRPr lang="en-US" sz="800" dirty="0"/>
+          </a:p>
+        </p:txBody>
+      </p:sp>
+      <p:sp>
+        <p:nvSpPr>
+          <p:cNvPr id="24" name="Shape 22"/>
           <p:cNvSpPr/>
           <p:nvPr/>
         </p:nvSpPr>
         <p:spPr>
           <a:xfrm>
-            <a:off x="8091221" y="3547872"/>
-            <a:ext cx="3533546" cy="1956816"/>
+            <a:off x="9031757" y="3419856"/>
+            <a:ext cx="2593010" cy="2084832"/>
           </a:xfrm>
           <a:prstGeom prst="roundRect">
             <a:avLst>
-              <a:gd name="adj" fmla="val 3738"/>
+              <a:gd name="adj" fmla="val 3509"/>
             </a:avLst>
           </a:prstGeom>
           <a:solidFill>
@@ -32328,14 +32600,14 @@
       </p:sp>
       <p:sp>
         <p:nvSpPr>
-          <p:cNvPr id="22" name="Text 20"/>
-          <p:cNvSpPr txBox="1"/>
-          <p:nvPr/>
-        </p:nvSpPr>
-        <p:spPr>
-          <a:xfrm>
-            <a:off x="8274101" y="3675888"/>
-            <a:ext cx="3167786" cy="219456"/>
+          <p:cNvPr id="25" name="Text 23"/>
+          <p:cNvSpPr txBox="1"/>
+          <p:nvPr/>
+        </p:nvSpPr>
+        <p:spPr>
+          <a:xfrm>
+            <a:off x="9214637" y="3547872"/>
+            <a:ext cx="2227250" cy="219456"/>
           </a:xfrm>
           <a:prstGeom prst="rect">
             <a:avLst/>
@@ -32359,7 +32631,7 @@
                 <a:ea typeface="Calibri" pitchFamily="34" charset="-122"/>
                 <a:cs typeface="Calibri" pitchFamily="34" charset="-120"/>
               </a:rPr>
-              <a:t>VIDÉO · RÉVÉLATION</a:t>
+              <a:t>PLAN 11 · INSERTION</a:t>
             </a:r>
             <a:endParaRPr lang="en-US" sz="900" dirty="0"/>
           </a:p>
@@ -32367,14 +32639,14 @@
       </p:sp>
       <p:sp>
         <p:nvSpPr>
-          <p:cNvPr id="23" name="Text 21"/>
-          <p:cNvSpPr txBox="1"/>
-          <p:nvPr/>
-        </p:nvSpPr>
-        <p:spPr>
-          <a:xfrm>
-            <a:off x="8274101" y="3931920"/>
-            <a:ext cx="3167786" cy="1426464"/>
+          <p:cNvPr id="26" name="Text 24"/>
+          <p:cNvSpPr txBox="1"/>
+          <p:nvPr/>
+        </p:nvSpPr>
+        <p:spPr>
+          <a:xfrm>
+            <a:off x="9214637" y="3803904"/>
+            <a:ext cx="2227250" cy="1554480"/>
           </a:xfrm>
           <a:prstGeom prst="rect">
             <a:avLst/>
@@ -32393,7 +32665,7 @@
               <a:buNone/>
             </a:pPr>
             <a:r>
-              <a:rPr lang="en-US" sz="900" dirty="0">
+              <a:rPr lang="en-US" sz="800" dirty="0">
                 <a:solidFill>
                   <a:srgbClr val="DFE5E8"/>
                 </a:solidFill>
@@ -32401,9 +32673,9 @@
                 <a:ea typeface="Consolas" pitchFamily="34" charset="-122"/>
                 <a:cs typeface="Consolas" pitchFamily="34" charset="-120"/>
               </a:rPr>
-              <a:t>Vue d'un [typologie] partiellement masqué</a:t>
-            </a:r>
-            <a:endParaRPr lang="en-US" sz="900" dirty="0"/>
+              <a:t>Un [typologie] vu depuis le</a:t>
+            </a:r>
+            <a:endParaRPr lang="en-US" sz="800" dirty="0"/>
           </a:p>
           <a:p>
             <a:pPr indent="0" marL="0">
@@ -32413,7 +32685,7 @@
               <a:buNone/>
             </a:pPr>
             <a:r>
-              <a:rPr lang="en-US" sz="900" dirty="0">
+              <a:rPr lang="en-US" sz="800" dirty="0">
                 <a:solidFill>
                   <a:srgbClr val="DFE5E8"/>
                 </a:solidFill>
@@ -32421,9 +32693,9 @@
                 <a:ea typeface="Consolas" pitchFamily="34" charset="-122"/>
                 <a:cs typeface="Consolas" pitchFamily="34" charset="-120"/>
               </a:rPr>
-              <a:t>par un premier plan de végétation.</a:t>
-            </a:r>
-            <a:endParaRPr lang="en-US" sz="900" dirty="0"/>
+              <a:t>trottoir opposé, hauteur d'œil</a:t>
+            </a:r>
+            <a:endParaRPr lang="en-US" sz="800" dirty="0"/>
           </a:p>
           <a:p>
             <a:pPr indent="0" marL="0">
@@ -32432,7 +32704,18 @@
               </a:lnSpc>
               <a:buNone/>
             </a:pPr>
-            <a:endParaRPr lang="en-US" sz="900" dirty="0"/>
+            <a:r>
+              <a:rPr lang="en-US" sz="800" dirty="0">
+                <a:solidFill>
+                  <a:srgbClr val="DFE5E8"/>
+                </a:solidFill>
+                <a:latin typeface="Consolas" pitchFamily="34" charset="0"/>
+                <a:ea typeface="Consolas" pitchFamily="34" charset="-122"/>
+                <a:cs typeface="Consolas" pitchFamily="34" charset="-120"/>
+              </a:rPr>
+              <a:t>1,60 m, fin d'après-midi.</a:t>
+            </a:r>
+            <a:endParaRPr lang="en-US" sz="800" dirty="0"/>
           </a:p>
           <a:p>
             <a:pPr indent="0" marL="0">
@@ -32441,8 +32724,17 @@
               </a:lnSpc>
               <a:buNone/>
             </a:pPr>
-            <a:r>
-              <a:rPr lang="en-US" sz="900" dirty="0">
+            <a:endParaRPr lang="en-US" sz="800" dirty="0"/>
+          </a:p>
+          <a:p>
+            <a:pPr indent="0" marL="0">
+              <a:lnSpc>
+                <a:spcPct val="100000"/>
+              </a:lnSpc>
+              <a:buNone/>
+            </a:pPr>
+            <a:r>
+              <a:rPr lang="en-US" sz="800" dirty="0">
                 <a:solidFill>
                   <a:srgbClr val="DFE5E8"/>
                 </a:solidFill>
@@ -32450,9 +32742,9 @@
                 <a:ea typeface="Consolas" pitchFamily="34" charset="-122"/>
                 <a:cs typeface="Consolas" pitchFamily="34" charset="-120"/>
               </a:rPr>
-              <a:t>La caméra se décale doucement vers la</a:t>
-            </a:r>
-            <a:endParaRPr lang="en-US" sz="900" dirty="0"/>
+              <a:t>Caméra : slow steadicam tracking.</a:t>
+            </a:r>
+            <a:endParaRPr lang="en-US" sz="800" dirty="0"/>
           </a:p>
           <a:p>
             <a:pPr indent="0" marL="0">
@@ -32462,7 +32754,7 @@
               <a:buNone/>
             </a:pPr>
             <a:r>
-              <a:rPr lang="en-US" sz="900" dirty="0">
+              <a:rPr lang="en-US" sz="800" dirty="0">
                 <a:solidFill>
                   <a:srgbClr val="DFE5E8"/>
                 </a:solidFill>
@@ -32470,9 +32762,9 @@
                 <a:ea typeface="Consolas" pitchFamily="34" charset="-122"/>
                 <a:cs typeface="Consolas" pitchFamily="34" charset="-120"/>
               </a:rPr>
-              <a:t>droite et découvre le bâtiment.</a:t>
-            </a:r>
-            <a:endParaRPr lang="en-US" sz="900" dirty="0"/>
+              <a:t>Elle longe le trottoir à vitesse de</a:t>
+            </a:r>
+            <a:endParaRPr lang="en-US" sz="800" dirty="0"/>
           </a:p>
           <a:p>
             <a:pPr indent="0" marL="0">
@@ -32482,7 +32774,7 @@
               <a:buNone/>
             </a:pPr>
             <a:r>
-              <a:rPr lang="en-US" sz="900" dirty="0">
+              <a:rPr lang="en-US" sz="800" dirty="0">
                 <a:solidFill>
                   <a:srgbClr val="DFE5E8"/>
                 </a:solidFill>
@@ -32490,9 +32782,9 @@
                 <a:ea typeface="Consolas" pitchFamily="34" charset="-122"/>
                 <a:cs typeface="Consolas" pitchFamily="34" charset="-120"/>
               </a:rPr>
-              <a:t>Mouvement lent, continu, régulier.</a:t>
-            </a:r>
-            <a:endParaRPr lang="en-US" sz="900" dirty="0"/>
+              <a:t>marche, distance constante.</a:t>
+            </a:r>
+            <a:endParaRPr lang="en-US" sz="800" dirty="0"/>
           </a:p>
           <a:p>
             <a:pPr indent="0" marL="0">
@@ -32501,7 +32793,7 @@
               </a:lnSpc>
               <a:buNone/>
             </a:pPr>
-            <a:endParaRPr lang="en-US" sz="900" dirty="0"/>
+            <a:endParaRPr lang="en-US" sz="800" dirty="0"/>
           </a:p>
           <a:p>
             <a:pPr indent="0" marL="0">
@@ -32511,7 +32803,7 @@
               <a:buNone/>
             </a:pPr>
             <a:r>
-              <a:rPr lang="en-US" sz="900" dirty="0">
+              <a:rPr lang="en-US" sz="800" dirty="0">
                 <a:solidFill>
                   <a:srgbClr val="DFE5E8"/>
                 </a:solidFill>
@@ -32519,9 +32811,9 @@
                 <a:ea typeface="Consolas" pitchFamily="34" charset="-122"/>
                 <a:cs typeface="Consolas" pitchFamily="34" charset="-120"/>
               </a:rPr>
-              <a:t>Le feuillage du premier plan bouge.</a:t>
-            </a:r>
-            <a:endParaRPr lang="en-US" sz="900" dirty="0"/>
+              <a:t>Les passants restent immobiles.</a:t>
+            </a:r>
+            <a:endParaRPr lang="en-US" sz="800" dirty="0"/>
           </a:p>
           <a:p>
             <a:pPr indent="0" marL="0">
@@ -32530,8 +32822,17 @@
               </a:lnSpc>
               <a:buNone/>
             </a:pPr>
-            <a:r>
-              <a:rPr lang="en-US" sz="900" dirty="0">
+            <a:endParaRPr lang="en-US" sz="800" dirty="0"/>
+          </a:p>
+          <a:p>
+            <a:pPr indent="0" marL="0">
+              <a:lnSpc>
+                <a:spcPct val="100000"/>
+              </a:lnSpc>
+              <a:buNone/>
+            </a:pPr>
+            <a:r>
+              <a:rPr lang="en-US" sz="800" dirty="0">
                 <a:solidFill>
                   <a:srgbClr val="DFE5E8"/>
                 </a:solidFill>
@@ -32539,35 +32840,15 @@
                 <a:ea typeface="Consolas" pitchFamily="34" charset="-122"/>
                 <a:cs typeface="Consolas" pitchFamily="34" charset="-120"/>
               </a:rPr>
-              <a:t>Ambiance sonore : vent léger.</a:t>
-            </a:r>
-            <a:endParaRPr lang="en-US" sz="900" dirty="0"/>
-          </a:p>
-          <a:p>
-            <a:pPr indent="0" marL="0">
-              <a:lnSpc>
-                <a:spcPct val="100000"/>
-              </a:lnSpc>
-              <a:buNone/>
-            </a:pPr>
-            <a:r>
-              <a:rPr lang="en-US" sz="900" dirty="0">
-                <a:solidFill>
-                  <a:srgbClr val="DFE5E8"/>
-                </a:solidFill>
-                <a:latin typeface="Consolas" pitchFamily="34" charset="0"/>
-                <a:ea typeface="Consolas" pitchFamily="34" charset="-122"/>
-                <a:cs typeface="Consolas" pitchFamily="34" charset="-120"/>
-              </a:rPr>
-              <a:t>Un seul plan, six secondes.</a:t>
-            </a:r>
-            <a:endParaRPr lang="en-US" sz="900" dirty="0"/>
-          </a:p>
-        </p:txBody>
-      </p:sp>
-      <p:sp>
-        <p:nvSpPr>
-          <p:cNvPr id="24" name="Shape 22"/>
+              <a:t>Un plan, huit secondes. Rue calme.</a:t>
+            </a:r>
+            <a:endParaRPr lang="en-US" sz="800" dirty="0"/>
+          </a:p>
+        </p:txBody>
+      </p:sp>
+      <p:sp>
+        <p:nvSpPr>
+          <p:cNvPr id="27" name="Shape 25"/>
           <p:cNvSpPr/>
           <p:nvPr/>
         </p:nvSpPr>
@@ -32589,7 +32870,7 @@
       </p:sp>
       <p:sp>
         <p:nvSpPr>
-          <p:cNvPr id="25" name="Shape 23"/>
+          <p:cNvPr id="28" name="Shape 26"/>
           <p:cNvSpPr/>
           <p:nvPr/>
         </p:nvSpPr>
@@ -32611,7 +32892,7 @@
       </p:sp>
       <p:sp>
         <p:nvSpPr>
-          <p:cNvPr id="26" name="Text 24"/>
+          <p:cNvPr id="29" name="Text 27"/>
           <p:cNvSpPr txBox="1"/>
           <p:nvPr/>
         </p:nvSpPr>
@@ -32650,7 +32931,7 @@
       </p:sp>
       <p:sp>
         <p:nvSpPr>
-          <p:cNvPr id="27" name="Text 25"/>
+          <p:cNvPr id="30" name="Text 28"/>
           <p:cNvSpPr txBox="1"/>
           <p:nvPr/>
         </p:nvSpPr>
@@ -32681,7 +32962,7 @@
                 <a:ea typeface="Calibri" pitchFamily="34" charset="-122"/>
                 <a:cs typeface="Calibri" pitchFamily="34" charset="-120"/>
               </a:rPr>
-              <a:t>Les crochets sont volontaires : remplissez-les avec votre propre vocabulaire. Un prompt entièrement pré-écrit ne devient jamais le vôtre — et c'est le vôtre qui vous fera gagner du temps.</a:t>
+              <a:t>Les quatre plans vidéo retenus sont ceux qui réussissent le plus souvent. Les huit autres — orbite, grue, tilt, traversée intérieure, détail de matière, passage du temps — sont dans la Grammaire vidéo Seedance, remise avec le support.</a:t>
             </a:r>
             <a:endParaRPr lang="en-US" sz="1200" dirty="0"/>
           </a:p>

</xml_diff>